<commit_message>
Match poster callout accents with medium gold
</commit_message>
<xml_diff>
--- a/benchmarks/iros-2026/poster/IROS-2026-Mech-Poster-spacing.pptx
+++ b/benchmarks/iros-2026/poster/IROS-2026-Mech-Poster-spacing.pptx
@@ -28323,7 +28323,7 @@
             <a:avLst/>
           </a:prstGeom>
           <a:solidFill xmlns:a="http://schemas.openxmlformats.org/drawingml/2006/main">
-            <a:srgbClr val="655943"/>
+            <a:srgbClr val="B89A5A"/>
           </a:solidFill>
           <a:ln xmlns:a="http://schemas.openxmlformats.org/drawingml/2006/main" w="0">
             <a:noFill/>
@@ -28414,7 +28414,7 @@
             <a:avLst/>
           </a:prstGeom>
           <a:solidFill xmlns:a="http://schemas.openxmlformats.org/drawingml/2006/main">
-            <a:srgbClr val="6B4A69"/>
+            <a:srgbClr val="B89A5A"/>
           </a:solidFill>
           <a:ln xmlns:a="http://schemas.openxmlformats.org/drawingml/2006/main" w="0">
             <a:noFill/>
@@ -28548,7 +28548,7 @@
             <a:hlinkClick xmlns:r="http://schemas.openxmlformats.org/officeDocument/2006/relationships" r:id="rId2"/>
             <a:extLst xmlns:a="http://schemas.openxmlformats.org/drawingml/2006/main">
               <a:ext uri="{FF2B5EF4-FFF2-40B4-BE49-F238E27FC236}">
-                <a16:creationId xmlns:a16="http://schemas.microsoft.com/office/drawing/2014/main" id="{B7E6C993-3A9A-4259-A9A1-37ACB1D8E921}"/>
+                <a16:creationId xmlns:a16="http://schemas.microsoft.com/office/drawing/2014/main" id="{1D7E2A7F-0678-49CD-A656-59A1D393B7CB}"/>
               </a:ext>
             </a:extLst>
           </p:cNvPr>
@@ -28609,7 +28609,7 @@
           <p:cNvPr id="840" name="QR invitation hook">
             <a:extLst xmlns:a="http://schemas.openxmlformats.org/drawingml/2006/main">
               <a:ext uri="{FF2B5EF4-FFF2-40B4-BE49-F238E27FC236}">
-                <a16:creationId xmlns:a16="http://schemas.microsoft.com/office/drawing/2014/main" id="{96C20AFB-B158-4817-8908-E8ED699A326D}"/>
+                <a16:creationId xmlns:a16="http://schemas.microsoft.com/office/drawing/2014/main" id="{C0EBE3D6-DA2F-4EDA-80DB-DF8898232BE8}"/>
               </a:ext>
             </a:extLst>
           </p:cNvPr>
@@ -28673,7 +28673,7 @@
           <p:cNvPr id="841" name="Benchmark setup title reference">
             <a:extLst xmlns:a="http://schemas.openxmlformats.org/drawingml/2006/main">
               <a:ext uri="{FF2B5EF4-FFF2-40B4-BE49-F238E27FC236}">
-                <a16:creationId xmlns:a16="http://schemas.microsoft.com/office/drawing/2014/main" id="{258F7359-0558-43C3-A8AC-0A29664AEE7F}"/>
+                <a16:creationId xmlns:a16="http://schemas.microsoft.com/office/drawing/2014/main" id="{28DC00C9-5266-4F55-BE6A-1B977BD42116}"/>
               </a:ext>
             </a:extLst>
           </p:cNvPr>
@@ -28734,7 +28734,7 @@
           <p:cNvPr id="842" name="EKF integrity constraint">
             <a:extLst xmlns:a="http://schemas.openxmlformats.org/drawingml/2006/main">
               <a:ext uri="{FF2B5EF4-FFF2-40B4-BE49-F238E27FC236}">
-                <a16:creationId xmlns:a16="http://schemas.microsoft.com/office/drawing/2014/main" id="{56C93A2F-A113-43F4-B5D3-B960F7F4B837}"/>
+                <a16:creationId xmlns:a16="http://schemas.microsoft.com/office/drawing/2014/main" id="{9D061235-1990-4AFC-A075-7BEE86FDC3A3}"/>
               </a:ext>
             </a:extLst>
           </p:cNvPr>
@@ -28856,7 +28856,7 @@
             <a:r>
               <a:rPr sz="2800">
                 <a:solidFill>
-                  <a:srgbClr val="EDDAF1"/>
+                  <a:srgbClr val="93C1E8"/>
                 </a:solidFill>
                 <a:latin typeface="Fira Code"/>
                 <a:ea typeface="Fira Code"/>
@@ -28928,7 +28928,7 @@
             <a:hlinkClick xmlns:r="http://schemas.openxmlformats.org/officeDocument/2006/relationships" r:id="rId3"/>
             <a:extLst xmlns:a="http://schemas.openxmlformats.org/drawingml/2006/main">
               <a:ext uri="{FF2B5EF4-FFF2-40B4-BE49-F238E27FC236}">
-                <a16:creationId xmlns:a16="http://schemas.microsoft.com/office/drawing/2014/main" id="{34691AFC-8CCE-4733-9AE3-7300225CB4B2}"/>
+                <a16:creationId xmlns:a16="http://schemas.microsoft.com/office/drawing/2014/main" id="{92850176-4A24-450B-836A-E30BD8F5DA9A}"/>
               </a:ext>
             </a:extLst>
           </p:cNvPr>
@@ -29011,7 +29011,7 @@
           <p:cNvPr id="844" name="Benchmark setup note reference">
             <a:extLst xmlns:a="http://schemas.openxmlformats.org/drawingml/2006/main">
               <a:ext uri="{FF2B5EF4-FFF2-40B4-BE49-F238E27FC236}">
-                <a16:creationId xmlns:a16="http://schemas.microsoft.com/office/drawing/2014/main" id="{1B7B8A15-8F9D-4884-8B9F-F4677ED2EF20}"/>
+                <a16:creationId xmlns:a16="http://schemas.microsoft.com/office/drawing/2014/main" id="{4EE9CF61-D51E-4B9F-8B23-826556D80EEB}"/>
               </a:ext>
             </a:extLst>
           </p:cNvPr>

</xml_diff>

<commit_message>
Unify resident computation labels and balance poster text
</commit_message>
<xml_diff>
--- a/benchmarks/iros-2026/poster/IROS-2026-Mech-Poster-spacing.pptx
+++ b/benchmarks/iros-2026/poster/IROS-2026-Mech-Poster-spacing.pptx
@@ -23575,7 +23575,7 @@
                 <a:ea typeface="Segoe UI"/>
                 <a:cs typeface="Segoe UI"/>
               </a:rPr>
-              <a:t>Resident instance</a:t>
+              <a:t>Resident computation</a:t>
             </a:r>
           </a:p>
         </p:txBody>
@@ -27857,7 +27857,7 @@
                 <a:ea typeface="Avenir Next"/>
                 <a:cs typeface="Avenir Next"/>
               </a:rPr>
-              <a:t>Rust’s memory safety and performance make it a strong foundation for robotics. Still, numerical kernels can require substantial code for SIMD layouts and GPU execution. Backend-specific implementations can be harder to verify against the equations and maintain.</a:t>
+              <a:t>Rust’s memory safety and per­for­mance make it a strong foun­da­tion for robotics. Still, nu­mer­i­cal kernels can require sub­stan­tial code for SIMD layouts and GPU ex­e­cu­tion. Backend-specific im­ple­men­ta­tions can be harder to verify against the equations and maintain.</a:t>
             </a:r>
           </a:p>
         </p:txBody>
@@ -27918,7 +27918,7 @@
                 <a:ea typeface="Avenir Next"/>
                 <a:cs typeface="Avenir Next"/>
               </a:rPr>
-              <a:t>Mech is an open-source, Rust-native embeddable language that aims to make numerical kernels easier to write in Rust. For robotics, it adds reactive semantics that process successive sensor updates, validate candidate state and retain the last accepted state when a turn fails.</a:t>
+              <a:t>Mech is an open-source, Rust-native em­bed­dable language that aims to make nu­mer­i­cal kernels easier to write in Rust. For robotics, it adds re­ac­tive semantics that process suc­ces­sive sensor updates, validate can­di­date state and retain the last accepted state when a turn fails.</a:t>
             </a:r>
           </a:p>
         </p:txBody>
@@ -28548,7 +28548,7 @@
             <a:hlinkClick xmlns:r="http://schemas.openxmlformats.org/officeDocument/2006/relationships" r:id="rId2"/>
             <a:extLst xmlns:a="http://schemas.openxmlformats.org/drawingml/2006/main">
               <a:ext uri="{FF2B5EF4-FFF2-40B4-BE49-F238E27FC236}">
-                <a16:creationId xmlns:a16="http://schemas.microsoft.com/office/drawing/2014/main" id="{1D7E2A7F-0678-49CD-A656-59A1D393B7CB}"/>
+                <a16:creationId xmlns:a16="http://schemas.microsoft.com/office/drawing/2014/main" id="{6ADE8C1B-F812-47D9-8751-4D68ACA56770}"/>
               </a:ext>
             </a:extLst>
           </p:cNvPr>
@@ -28609,7 +28609,7 @@
           <p:cNvPr id="840" name="QR invitation hook">
             <a:extLst xmlns:a="http://schemas.openxmlformats.org/drawingml/2006/main">
               <a:ext uri="{FF2B5EF4-FFF2-40B4-BE49-F238E27FC236}">
-                <a16:creationId xmlns:a16="http://schemas.microsoft.com/office/drawing/2014/main" id="{C0EBE3D6-DA2F-4EDA-80DB-DF8898232BE8}"/>
+                <a16:creationId xmlns:a16="http://schemas.microsoft.com/office/drawing/2014/main" id="{5D82B73E-F2EC-47C0-9AFF-802F5EB68028}"/>
               </a:ext>
             </a:extLst>
           </p:cNvPr>
@@ -28673,7 +28673,7 @@
           <p:cNvPr id="841" name="Benchmark setup title reference">
             <a:extLst xmlns:a="http://schemas.openxmlformats.org/drawingml/2006/main">
               <a:ext uri="{FF2B5EF4-FFF2-40B4-BE49-F238E27FC236}">
-                <a16:creationId xmlns:a16="http://schemas.microsoft.com/office/drawing/2014/main" id="{28DC00C9-5266-4F55-BE6A-1B977BD42116}"/>
+                <a16:creationId xmlns:a16="http://schemas.microsoft.com/office/drawing/2014/main" id="{42D6F962-7EE6-4B9D-9E97-C1590F804BB5}"/>
               </a:ext>
             </a:extLst>
           </p:cNvPr>
@@ -28734,7 +28734,7 @@
           <p:cNvPr id="842" name="EKF integrity constraint">
             <a:extLst xmlns:a="http://schemas.openxmlformats.org/drawingml/2006/main">
               <a:ext uri="{FF2B5EF4-FFF2-40B4-BE49-F238E27FC236}">
-                <a16:creationId xmlns:a16="http://schemas.microsoft.com/office/drawing/2014/main" id="{9D061235-1990-4AFC-A075-7BEE86FDC3A3}"/>
+                <a16:creationId xmlns:a16="http://schemas.microsoft.com/office/drawing/2014/main" id="{BB9B39EC-5AB5-4A66-9059-747376F98062}"/>
               </a:ext>
             </a:extLst>
           </p:cNvPr>
@@ -28928,7 +28928,7 @@
             <a:hlinkClick xmlns:r="http://schemas.openxmlformats.org/officeDocument/2006/relationships" r:id="rId3"/>
             <a:extLst xmlns:a="http://schemas.openxmlformats.org/drawingml/2006/main">
               <a:ext uri="{FF2B5EF4-FFF2-40B4-BE49-F238E27FC236}">
-                <a16:creationId xmlns:a16="http://schemas.microsoft.com/office/drawing/2014/main" id="{92850176-4A24-450B-836A-E30BD8F5DA9A}"/>
+                <a16:creationId xmlns:a16="http://schemas.microsoft.com/office/drawing/2014/main" id="{1CEF8EC6-C0BB-40D7-A6E6-C8E9F1B01E18}"/>
               </a:ext>
             </a:extLst>
           </p:cNvPr>
@@ -29011,7 +29011,7 @@
           <p:cNvPr id="844" name="Benchmark setup note reference">
             <a:extLst xmlns:a="http://schemas.openxmlformats.org/drawingml/2006/main">
               <a:ext uri="{FF2B5EF4-FFF2-40B4-BE49-F238E27FC236}">
-                <a16:creationId xmlns:a16="http://schemas.microsoft.com/office/drawing/2014/main" id="{4EE9CF61-D51E-4B9F-8B23-826556D80EEB}"/>
+                <a16:creationId xmlns:a16="http://schemas.microsoft.com/office/drawing/2014/main" id="{36FF6434-F66E-4F00-BD64-3B9D9AAAD5AB}"/>
               </a:ext>
             </a:extLst>
           </p:cNvPr>

</xml_diff>